<commit_message>
Fix initial-frame preprocessing and refresh lab 2 results
</commit_message>
<xml_diff>
--- a/results/lab2/lab2_slides.pptx
+++ b/results/lab2/lab2_slides.pptx
@@ -2,18 +2,18 @@
 <file path=ppt/presentation.xml><?xml version="1.0" encoding="utf-8"?>
 <p:presentation xmlns:p="http://schemas.openxmlformats.org/presentationml/2006/main">
   <p:sldMasterIdLst>
-    <p:sldMasterId xmlns:r="http://schemas.openxmlformats.org/officeDocument/2006/relationships" id="2147483648" r:id="R73ed13d8cfb54bed"/>
+    <p:sldMasterId xmlns:r="http://schemas.openxmlformats.org/officeDocument/2006/relationships" id="2147483648" r:id="Rbebcce88243144ee"/>
   </p:sldMasterIdLst>
   <p:notesMasterIdLst>
-    <p:notesMasterId xmlns:r="http://schemas.openxmlformats.org/officeDocument/2006/relationships" r:id="R4f54b89b7ec74a8d"/>
+    <p:notesMasterId xmlns:r="http://schemas.openxmlformats.org/officeDocument/2006/relationships" r:id="Rfa614fef554f4dc9"/>
   </p:notesMasterIdLst>
   <p:sldIdLst>
-    <p:sldId xmlns:r="http://schemas.openxmlformats.org/officeDocument/2006/relationships" id="256" r:id="Raebdb21ffcab4ed7"/>
-    <p:sldId xmlns:r="http://schemas.openxmlformats.org/officeDocument/2006/relationships" id="257" r:id="Rd4a706e93e51497c"/>
-    <p:sldId xmlns:r="http://schemas.openxmlformats.org/officeDocument/2006/relationships" id="258" r:id="Rf69c7edb218240f4"/>
-    <p:sldId xmlns:r="http://schemas.openxmlformats.org/officeDocument/2006/relationships" id="259" r:id="R1b025f0e31ec47c4"/>
-    <p:sldId xmlns:r="http://schemas.openxmlformats.org/officeDocument/2006/relationships" id="260" r:id="Rf3f97987f5ec413d"/>
-    <p:sldId xmlns:r="http://schemas.openxmlformats.org/officeDocument/2006/relationships" id="261" r:id="R42d3807b4c3c4a0b"/>
+    <p:sldId xmlns:r="http://schemas.openxmlformats.org/officeDocument/2006/relationships" id="256" r:id="Rf859b8f453714204"/>
+    <p:sldId xmlns:r="http://schemas.openxmlformats.org/officeDocument/2006/relationships" id="257" r:id="R6aa1d64986544e78"/>
+    <p:sldId xmlns:r="http://schemas.openxmlformats.org/officeDocument/2006/relationships" id="258" r:id="Rd424535b55314d77"/>
+    <p:sldId xmlns:r="http://schemas.openxmlformats.org/officeDocument/2006/relationships" id="259" r:id="R5bc20d1a739d43f9"/>
+    <p:sldId xmlns:r="http://schemas.openxmlformats.org/officeDocument/2006/relationships" id="260" r:id="R966d14dddd5b493a"/>
+    <p:sldId xmlns:r="http://schemas.openxmlformats.org/officeDocument/2006/relationships" id="261" r:id="R90abc5e443724525"/>
   </p:sldIdLst>
   <p:sldSz cx="12192000" cy="6858000"/>
   <p:notesSz cx="6858000" cy="9144000"/>
@@ -602,7 +602,7 @@
           <a:lstStyle xmlns:a="http://schemas.openxmlformats.org/drawingml/2006/main"/>
           <a:p xmlns:a="http://schemas.openxmlformats.org/drawingml/2006/main">
             <a:r>
-              <a:t>Первые 120 кадров разбиты на 12 непересекающихся временных окон. На каждом окне я решаю линейную задачу МНК по двум уравнениям сразу, через SVD. Из 12 векторов считаю среднее и полную ковариационную матрицу, затем использую гауссову аппроксимацию. Поздние кадры отделены четырьмя пропущенными кадрами. Они не участвуют в подборе. Это разброс оценок по окнам, а не байесовский posterior. Окна внешней траектории могут быть зависимы. В пространстве параметров локальная метрика равна обратной ковариации. Для ковариаций отдельно использована аффинно-инвариантная геометрия SPD. Она дополняет основную KL и не заменяет её.</a:t>
+              <a:t>Для цилиндра я сначала исключил исходный кадр t=0. При его включении в разностный шаблон оценка на t=0,2 сильно отличается от соседних, и одно окно определяет почти весь разброс параметров. После исключения кадра первые производные получаются при t=0,3. Первые 120 доступных кадров разбиты на 12 непересекающихся временных окон. На каждом окне решаю МНК по двум уравнениям сразу, через SVD. Из 12 векторов считаю среднее и полную ковариацию, затем использую гауссову аппроксимацию. Для цилиндра обучение идёт от t=0,3 до 12,2, проверка от 12,7 до 19,7. Между ними пропущены четыре кадра, чтобы временные шаблоны не пересекались. Это разброс оценок по окнам; сами окна могут быть зависимы. Метрика параметров равна обратной ковариации. Геометрию самих ковариаций отдельно рассматриваю на SPD.</a:t>
             </a:r>
           </a:p>
           <a:p xmlns:a="http://schemas.openxmlformats.org/drawingml/2006/main">
@@ -677,12 +677,12 @@
           <a:lstStyle xmlns:a="http://schemas.openxmlformats.org/drawingml/2006/main"/>
           <a:p xmlns:a="http://schemas.openxmlformats.org/drawingml/2006/main">
             <a:r>
-              <a:t>Синтетический пример — точный вихрь Тейлора — Грина. В наблюдаемые ускорения добавлена погрешность один процент RMS, скорости и давление точные. При уменьшении давления оценка β уменьшается почти как один минус α. Вязкость остаётся около 0,01. После переоценки ошибка ускорения остаётся примерно 1,14 процента: конвекция и градиент давления в этом течении компенсируют друг друга. Но распределение β сдвигается на величину, которая намного больше исходного разброса, и KL очень велика. Поэтому малой ошибки недостаточно для удаления давления.</a:t>
+              <a:t>Синтетический пример — вихрь Тейлора — Грина. В ускорения добавлена погрешность один процент RMS, скорости и давление точные. Здесь конвекция уравновешена градиентом давления. Поэтому при уменьшении давления β уменьшается почти как один минус α, а вязкость остаётся около 0,01. После подбора ошибка всё время около 1,14 процента. На этой траектории одной ошибки недостаточно, чтобы выбрать между полной моделью и моделью без давления с β=0. По нашему правилу давление сохраняем: распределение β сильно сдвинулось, поэтому KL велика.</a:t>
             </a:r>
           </a:p>
           <a:p xmlns:a="http://schemas.openxmlformats.org/drawingml/2006/main">
             <a:r>
-              <a:t>Числа: results/lab2/metrics.json, раздел Тейлор — Грин. Формулы точного решения приведены в ноутбуке lab2.ipynb.</a:t>
+              <a:t>Числа: results/lab2/metrics.json, раздел Тейлор — Грин. Формулы решения приведены в notebooks/lab2.ipynb.</a:t>
             </a:r>
           </a:p>
         </p:txBody>
@@ -752,7 +752,12 @@
           <a:lstStyle xmlns:a="http://schemas.openxmlformats.org/drawingml/2006/main"/>
           <a:p xmlns:a="http://schemas.openxmlformats.org/drawingml/2006/main">
             <a:r>
-              <a:t>Для внешней проверки использованы опубликованные данные Nektar++ о следе за цилиндром при Re=100, из открытых материалов Raissi и соавторов. Это численная симуляция. В ней есть давление, которого нет в загруженном Иваном файле PDEBench. Сохраняется та же система уравнений. На исходных данных найдено β=0,999429 и ν=0,010030. При полном занулении давления получаем β=0,797537 и ν=0,005644, а ошибка ускорения на поздних кадрах возрастает с 0,268 до 45,252 процента. KL в выбранном направлении примерно 250 нат. Оценка будущего течения здесь не проводится: сравниваются ускорения, вычисленные из локального уравнения.</a:t>
+              <a:t>Для внешней проверки взял данные течения за цилиндром при Re=100 из материалов Raissi и соавторов. Это численный расчёт Nektar++, а не измерения. Здесь есть давление, которого нет в загруженном Иваном файле PDEBench. На исходных данных после обработки начального участка получил β=0,999966 и ν=0,010005. После зануления давления β=0,798099, ν=0,005616. Ошибка ускорения на отложенных кадрах выросла с 0,261 до 45,273 процента. KL примерно 253 нат.</a:t>
+            </a:r>
+          </a:p>
+          <a:p xmlns:a="http://schemas.openxmlformats.org/drawingml/2006/main">
+            <a:r>
+              <a:t>Я отдельно сравнил расчёт с исходным первым кадром и без него. Число обусловленности исходной ковариации уменьшилось с 9,36·10⁶ до 89,6. При этом KL изменилась примерно с 250 до 253, а ошибка после зануления осталась около 45 процентов. Поэтому решение сохранить давление не зависит от этого начального кадра. Здесь проверяются ускорения по локальному уравнению, а не новая траектория течения.</a:t>
             </a:r>
           </a:p>
           <a:p xmlns:a="http://schemas.openxmlformats.org/drawingml/2006/main">
@@ -3275,12 +3280,12 @@
   </p:cSld>
   <p:clrMap bg1="lt1" tx1="dk1" bg2="lt2" tx2="dk2" accent1="accent1" accent2="accent2" accent3="accent3" accent4="accent4" accent5="accent5" accent6="accent6" hlink="hlink" folHlink="folHlink"/>
   <p:sldLayoutIdLst>
-    <p:sldLayoutId xmlns:r="http://schemas.openxmlformats.org/officeDocument/2006/relationships" id="2147483649" r:id="Ra74efc5cea1b41ff"/>
-    <p:sldLayoutId xmlns:r="http://schemas.openxmlformats.org/officeDocument/2006/relationships" id="2147483650" r:id="R827403cf72d24132"/>
-    <p:sldLayoutId xmlns:r="http://schemas.openxmlformats.org/officeDocument/2006/relationships" id="2147483651" r:id="R4817ec98eb9047eb"/>
-    <p:sldLayoutId xmlns:r="http://schemas.openxmlformats.org/officeDocument/2006/relationships" id="2147483652" r:id="R095ee2ad78fe472e"/>
-    <p:sldLayoutId xmlns:r="http://schemas.openxmlformats.org/officeDocument/2006/relationships" id="2147483653" r:id="Re0d3f94cb0e84da8"/>
-    <p:sldLayoutId xmlns:r="http://schemas.openxmlformats.org/officeDocument/2006/relationships" id="2147483654" r:id="R120928665eb749f1"/>
+    <p:sldLayoutId xmlns:r="http://schemas.openxmlformats.org/officeDocument/2006/relationships" id="2147483649" r:id="Rc3fcda7ffb16404d"/>
+    <p:sldLayoutId xmlns:r="http://schemas.openxmlformats.org/officeDocument/2006/relationships" id="2147483650" r:id="Re4be696bb6294de9"/>
+    <p:sldLayoutId xmlns:r="http://schemas.openxmlformats.org/officeDocument/2006/relationships" id="2147483651" r:id="R053434cbf5874ad9"/>
+    <p:sldLayoutId xmlns:r="http://schemas.openxmlformats.org/officeDocument/2006/relationships" id="2147483652" r:id="Re6815b4f44f74481"/>
+    <p:sldLayoutId xmlns:r="http://schemas.openxmlformats.org/officeDocument/2006/relationships" id="2147483653" r:id="R304535dc8aa8492c"/>
+    <p:sldLayoutId xmlns:r="http://schemas.openxmlformats.org/officeDocument/2006/relationships" id="2147483654" r:id="R7788d2eefe85415f"/>
   </p:sldLayoutIdLst>
   <p:txStyles>
     <p:titleStyle>
@@ -3826,6 +3831,7 @@
               <a:solidFill>
                 <a:srgbClr val="2962A3"/>
               </a:solidFill>
+              <a:prstDash val="solid"/>
             </a:ln>
           </c:spPr>
           <c:marker>
@@ -3988,6 +3994,7 @@
               <a:solidFill>
                 <a:srgbClr val="DCE2E8"/>
               </a:solidFill>
+              <a:prstDash val="solid"/>
             </a:ln>
           </c:spPr>
         </c:majorGridlines>
@@ -4091,6 +4098,7 @@
               <a:solidFill>
                 <a:srgbClr val="2962A3"/>
               </a:solidFill>
+              <a:prstDash val="solid"/>
             </a:ln>
           </c:spPr>
           <c:marker>
@@ -4127,19 +4135,19 @@
                 <c:formatCode>0%</c:formatCode>
                 <c:ptCount val="5"/>
                 <c:pt idx="0">
-                  <c:v>0.0026809857847</c:v>
+                  <c:v>0.00260706928894</c:v>
                 </c:pt>
                 <c:pt idx="1">
-                  <c:v>0.11315932169</c:v>
+                  <c:v>0.113211301931</c:v>
                 </c:pt>
                 <c:pt idx="2">
-                  <c:v>0.226272555268</c:v>
+                  <c:v>0.226377251597</c:v>
                 </c:pt>
                 <c:pt idx="3">
-                  <c:v>0.339396374806</c:v>
+                  <c:v>0.339553206844</c:v>
                 </c:pt>
                 <c:pt idx="4">
-                  <c:v>0.452522841386</c:v>
+                  <c:v>0.452731664009</c:v>
                 </c:pt>
               </c:numCache>
             </c:numRef>
@@ -4253,6 +4261,7 @@
               <a:solidFill>
                 <a:srgbClr val="DCE2E8"/>
               </a:solidFill>
+              <a:prstDash val="solid"/>
             </a:ln>
           </c:spPr>
         </c:majorGridlines>
@@ -4390,35 +4399,45 @@
               <a:defRPr sz="3300"/>
             </a:defPPr>
             <a:lvl1pPr>
+              <a:buNone/>
               <a:defRPr sz="3300"/>
             </a:lvl1pPr>
             <a:lvl2pPr>
+              <a:buNone/>
               <a:defRPr sz="3300"/>
             </a:lvl2pPr>
             <a:lvl3pPr>
+              <a:buNone/>
               <a:defRPr sz="3300"/>
             </a:lvl3pPr>
             <a:lvl4pPr>
+              <a:buNone/>
               <a:defRPr sz="3300"/>
             </a:lvl4pPr>
             <a:lvl5pPr>
+              <a:buNone/>
               <a:defRPr sz="3300"/>
             </a:lvl5pPr>
             <a:lvl6pPr>
+              <a:buNone/>
               <a:defRPr sz="3300"/>
             </a:lvl6pPr>
             <a:lvl7pPr>
+              <a:buNone/>
               <a:defRPr sz="3300"/>
             </a:lvl7pPr>
             <a:lvl8pPr>
+              <a:buNone/>
               <a:defRPr sz="3300"/>
             </a:lvl8pPr>
             <a:lvl9pPr>
+              <a:buNone/>
               <a:defRPr sz="3300"/>
             </a:lvl9pPr>
           </a:lstStyle>
           <a:p xmlns:a="http://schemas.openxmlformats.org/drawingml/2006/main">
             <a:pPr>
+              <a:buNone/>
               <a:defRPr sz="3300"/>
             </a:pPr>
             <a:r>
@@ -4490,35 +4509,45 @@
               <a:defRPr sz="2400"/>
             </a:defPPr>
             <a:lvl1pPr>
+              <a:buNone/>
               <a:defRPr sz="2400"/>
             </a:lvl1pPr>
             <a:lvl2pPr>
+              <a:buNone/>
               <a:defRPr sz="2400"/>
             </a:lvl2pPr>
             <a:lvl3pPr>
+              <a:buNone/>
               <a:defRPr sz="2400"/>
             </a:lvl3pPr>
             <a:lvl4pPr>
+              <a:buNone/>
               <a:defRPr sz="2400"/>
             </a:lvl4pPr>
             <a:lvl5pPr>
+              <a:buNone/>
               <a:defRPr sz="2400"/>
             </a:lvl5pPr>
             <a:lvl6pPr>
+              <a:buNone/>
               <a:defRPr sz="2400"/>
             </a:lvl6pPr>
             <a:lvl7pPr>
+              <a:buNone/>
               <a:defRPr sz="2400"/>
             </a:lvl7pPr>
             <a:lvl8pPr>
+              <a:buNone/>
               <a:defRPr sz="2400"/>
             </a:lvl8pPr>
             <a:lvl9pPr>
+              <a:buNone/>
               <a:defRPr sz="2400"/>
             </a:lvl9pPr>
           </a:lstStyle>
           <a:p xmlns:a="http://schemas.openxmlformats.org/drawingml/2006/main">
             <a:pPr>
+              <a:buNone/>
               <a:defRPr sz="2400"/>
             </a:pPr>
             <a:r>
@@ -4569,35 +4598,45 @@
               <a:defRPr sz="2850"/>
             </a:defPPr>
             <a:lvl1pPr>
+              <a:buNone/>
               <a:defRPr sz="2850"/>
             </a:lvl1pPr>
             <a:lvl2pPr>
+              <a:buNone/>
               <a:defRPr sz="2850"/>
             </a:lvl2pPr>
             <a:lvl3pPr>
+              <a:buNone/>
               <a:defRPr sz="2850"/>
             </a:lvl3pPr>
             <a:lvl4pPr>
+              <a:buNone/>
               <a:defRPr sz="2850"/>
             </a:lvl4pPr>
             <a:lvl5pPr>
+              <a:buNone/>
               <a:defRPr sz="2850"/>
             </a:lvl5pPr>
             <a:lvl6pPr>
+              <a:buNone/>
               <a:defRPr sz="2850"/>
             </a:lvl6pPr>
             <a:lvl7pPr>
+              <a:buNone/>
               <a:defRPr sz="2850"/>
             </a:lvl7pPr>
             <a:lvl8pPr>
+              <a:buNone/>
               <a:defRPr sz="2850"/>
             </a:lvl8pPr>
             <a:lvl9pPr>
+              <a:buNone/>
               <a:defRPr sz="2850"/>
             </a:lvl9pPr>
           </a:lstStyle>
           <a:p xmlns:a="http://schemas.openxmlformats.org/drawingml/2006/main">
             <a:pPr>
+              <a:buNone/>
               <a:defRPr sz="2850"/>
             </a:pPr>
             <a:r>
@@ -4648,35 +4687,45 @@
               <a:defRPr sz="2175"/>
             </a:defPPr>
             <a:lvl1pPr>
+              <a:buNone/>
               <a:defRPr sz="2175"/>
             </a:lvl1pPr>
             <a:lvl2pPr>
+              <a:buNone/>
               <a:defRPr sz="2175"/>
             </a:lvl2pPr>
             <a:lvl3pPr>
+              <a:buNone/>
               <a:defRPr sz="2175"/>
             </a:lvl3pPr>
             <a:lvl4pPr>
+              <a:buNone/>
               <a:defRPr sz="2175"/>
             </a:lvl4pPr>
             <a:lvl5pPr>
+              <a:buNone/>
               <a:defRPr sz="2175"/>
             </a:lvl5pPr>
             <a:lvl6pPr>
+              <a:buNone/>
               <a:defRPr sz="2175"/>
             </a:lvl6pPr>
             <a:lvl7pPr>
+              <a:buNone/>
               <a:defRPr sz="2175"/>
             </a:lvl7pPr>
             <a:lvl8pPr>
+              <a:buNone/>
               <a:defRPr sz="2175"/>
             </a:lvl8pPr>
             <a:lvl9pPr>
+              <a:buNone/>
               <a:defRPr sz="2175"/>
             </a:lvl9pPr>
           </a:lstStyle>
           <a:p xmlns:a="http://schemas.openxmlformats.org/drawingml/2006/main">
             <a:pPr>
+              <a:buNone/>
               <a:defRPr sz="2175"/>
             </a:pPr>
             <a:r>
@@ -4769,35 +4818,45 @@
               <a:defRPr sz="1650"/>
             </a:defPPr>
             <a:lvl1pPr>
+              <a:buNone/>
               <a:defRPr sz="1650"/>
             </a:lvl1pPr>
             <a:lvl2pPr>
+              <a:buNone/>
               <a:defRPr sz="1650"/>
             </a:lvl2pPr>
             <a:lvl3pPr>
+              <a:buNone/>
               <a:defRPr sz="1650"/>
             </a:lvl3pPr>
             <a:lvl4pPr>
+              <a:buNone/>
               <a:defRPr sz="1650"/>
             </a:lvl4pPr>
             <a:lvl5pPr>
+              <a:buNone/>
               <a:defRPr sz="1650"/>
             </a:lvl5pPr>
             <a:lvl6pPr>
+              <a:buNone/>
               <a:defRPr sz="1650"/>
             </a:lvl6pPr>
             <a:lvl7pPr>
+              <a:buNone/>
               <a:defRPr sz="1650"/>
             </a:lvl7pPr>
             <a:lvl8pPr>
+              <a:buNone/>
               <a:defRPr sz="1650"/>
             </a:lvl8pPr>
             <a:lvl9pPr>
+              <a:buNone/>
               <a:defRPr sz="1650"/>
             </a:lvl9pPr>
           </a:lstStyle>
           <a:p xmlns:a="http://schemas.openxmlformats.org/drawingml/2006/main">
             <a:pPr>
+              <a:buNone/>
               <a:defRPr sz="1650"/>
             </a:pPr>
             <a:r>
@@ -4877,35 +4936,45 @@
               <a:defRPr sz="3300"/>
             </a:defPPr>
             <a:lvl1pPr>
+              <a:buNone/>
               <a:defRPr sz="3300"/>
             </a:lvl1pPr>
             <a:lvl2pPr>
+              <a:buNone/>
               <a:defRPr sz="3300"/>
             </a:lvl2pPr>
             <a:lvl3pPr>
+              <a:buNone/>
               <a:defRPr sz="3300"/>
             </a:lvl3pPr>
             <a:lvl4pPr>
+              <a:buNone/>
               <a:defRPr sz="3300"/>
             </a:lvl4pPr>
             <a:lvl5pPr>
+              <a:buNone/>
               <a:defRPr sz="3300"/>
             </a:lvl5pPr>
             <a:lvl6pPr>
+              <a:buNone/>
               <a:defRPr sz="3300"/>
             </a:lvl6pPr>
             <a:lvl7pPr>
+              <a:buNone/>
               <a:defRPr sz="3300"/>
             </a:lvl7pPr>
             <a:lvl8pPr>
+              <a:buNone/>
               <a:defRPr sz="3300"/>
             </a:lvl8pPr>
             <a:lvl9pPr>
+              <a:buNone/>
               <a:defRPr sz="3300"/>
             </a:lvl9pPr>
           </a:lstStyle>
           <a:p xmlns:a="http://schemas.openxmlformats.org/drawingml/2006/main">
             <a:pPr>
+              <a:buNone/>
               <a:defRPr sz="3300"/>
             </a:pPr>
             <a:r>
@@ -4956,35 +5025,45 @@
               <a:defRPr sz="2550"/>
             </a:defPPr>
             <a:lvl1pPr>
+              <a:buNone/>
               <a:defRPr sz="2550"/>
             </a:lvl1pPr>
             <a:lvl2pPr>
+              <a:buNone/>
               <a:defRPr sz="2550"/>
             </a:lvl2pPr>
             <a:lvl3pPr>
+              <a:buNone/>
               <a:defRPr sz="2550"/>
             </a:lvl3pPr>
             <a:lvl4pPr>
+              <a:buNone/>
               <a:defRPr sz="2550"/>
             </a:lvl4pPr>
             <a:lvl5pPr>
+              <a:buNone/>
               <a:defRPr sz="2550"/>
             </a:lvl5pPr>
             <a:lvl6pPr>
+              <a:buNone/>
               <a:defRPr sz="2550"/>
             </a:lvl6pPr>
             <a:lvl7pPr>
+              <a:buNone/>
               <a:defRPr sz="2550"/>
             </a:lvl7pPr>
             <a:lvl8pPr>
+              <a:buNone/>
               <a:defRPr sz="2550"/>
             </a:lvl8pPr>
             <a:lvl9pPr>
+              <a:buNone/>
               <a:defRPr sz="2550"/>
             </a:lvl9pPr>
           </a:lstStyle>
           <a:p xmlns:a="http://schemas.openxmlformats.org/drawingml/2006/main">
             <a:pPr>
+              <a:buNone/>
               <a:defRPr sz="2550"/>
             </a:pPr>
             <a:r>
@@ -5056,35 +5135,45 @@
               <a:defRPr sz="2175"/>
             </a:defPPr>
             <a:lvl1pPr>
+              <a:buNone/>
               <a:defRPr sz="2175"/>
             </a:lvl1pPr>
             <a:lvl2pPr>
+              <a:buNone/>
               <a:defRPr sz="2175"/>
             </a:lvl2pPr>
             <a:lvl3pPr>
+              <a:buNone/>
               <a:defRPr sz="2175"/>
             </a:lvl3pPr>
             <a:lvl4pPr>
+              <a:buNone/>
               <a:defRPr sz="2175"/>
             </a:lvl4pPr>
             <a:lvl5pPr>
+              <a:buNone/>
               <a:defRPr sz="2175"/>
             </a:lvl5pPr>
             <a:lvl6pPr>
+              <a:buNone/>
               <a:defRPr sz="2175"/>
             </a:lvl6pPr>
             <a:lvl7pPr>
+              <a:buNone/>
               <a:defRPr sz="2175"/>
             </a:lvl7pPr>
             <a:lvl8pPr>
+              <a:buNone/>
               <a:defRPr sz="2175"/>
             </a:lvl8pPr>
             <a:lvl9pPr>
+              <a:buNone/>
               <a:defRPr sz="2175"/>
             </a:lvl9pPr>
           </a:lstStyle>
           <a:p xmlns:a="http://schemas.openxmlformats.org/drawingml/2006/main">
             <a:pPr>
+              <a:buNone/>
               <a:defRPr sz="2175"/>
             </a:pPr>
             <a:r>
@@ -5156,35 +5245,45 @@
               <a:defRPr sz="2250"/>
             </a:defPPr>
             <a:lvl1pPr>
+              <a:buNone/>
               <a:defRPr sz="2250"/>
             </a:lvl1pPr>
             <a:lvl2pPr>
+              <a:buNone/>
               <a:defRPr sz="2250"/>
             </a:lvl2pPr>
             <a:lvl3pPr>
+              <a:buNone/>
               <a:defRPr sz="2250"/>
             </a:lvl3pPr>
             <a:lvl4pPr>
+              <a:buNone/>
               <a:defRPr sz="2250"/>
             </a:lvl4pPr>
             <a:lvl5pPr>
+              <a:buNone/>
               <a:defRPr sz="2250"/>
             </a:lvl5pPr>
             <a:lvl6pPr>
+              <a:buNone/>
               <a:defRPr sz="2250"/>
             </a:lvl6pPr>
             <a:lvl7pPr>
+              <a:buNone/>
               <a:defRPr sz="2250"/>
             </a:lvl7pPr>
             <a:lvl8pPr>
+              <a:buNone/>
               <a:defRPr sz="2250"/>
             </a:lvl8pPr>
             <a:lvl9pPr>
+              <a:buNone/>
               <a:defRPr sz="2250"/>
             </a:lvl9pPr>
           </a:lstStyle>
           <a:p xmlns:a="http://schemas.openxmlformats.org/drawingml/2006/main">
             <a:pPr>
+              <a:buNone/>
               <a:defRPr sz="2250"/>
             </a:pPr>
             <a:r>
@@ -5285,35 +5384,45 @@
               <a:defRPr sz="3300"/>
             </a:defPPr>
             <a:lvl1pPr>
+              <a:buNone/>
               <a:defRPr sz="3300"/>
             </a:lvl1pPr>
             <a:lvl2pPr>
+              <a:buNone/>
               <a:defRPr sz="3300"/>
             </a:lvl2pPr>
             <a:lvl3pPr>
+              <a:buNone/>
               <a:defRPr sz="3300"/>
             </a:lvl3pPr>
             <a:lvl4pPr>
+              <a:buNone/>
               <a:defRPr sz="3300"/>
             </a:lvl4pPr>
             <a:lvl5pPr>
+              <a:buNone/>
               <a:defRPr sz="3300"/>
             </a:lvl5pPr>
             <a:lvl6pPr>
+              <a:buNone/>
               <a:defRPr sz="3300"/>
             </a:lvl6pPr>
             <a:lvl7pPr>
+              <a:buNone/>
               <a:defRPr sz="3300"/>
             </a:lvl7pPr>
             <a:lvl8pPr>
+              <a:buNone/>
               <a:defRPr sz="3300"/>
             </a:lvl8pPr>
             <a:lvl9pPr>
+              <a:buNone/>
               <a:defRPr sz="3300"/>
             </a:lvl9pPr>
           </a:lstStyle>
           <a:p xmlns:a="http://schemas.openxmlformats.org/drawingml/2006/main">
             <a:pPr>
+              <a:buNone/>
               <a:defRPr sz="3300"/>
             </a:pPr>
             <a:r>
@@ -5364,35 +5473,45 @@
               <a:defRPr sz="2325"/>
             </a:defPPr>
             <a:lvl1pPr>
+              <a:buNone/>
               <a:defRPr sz="2325"/>
             </a:lvl1pPr>
             <a:lvl2pPr>
+              <a:buNone/>
               <a:defRPr sz="2325"/>
             </a:lvl2pPr>
             <a:lvl3pPr>
+              <a:buNone/>
               <a:defRPr sz="2325"/>
             </a:lvl3pPr>
             <a:lvl4pPr>
+              <a:buNone/>
               <a:defRPr sz="2325"/>
             </a:lvl4pPr>
             <a:lvl5pPr>
+              <a:buNone/>
               <a:defRPr sz="2325"/>
             </a:lvl5pPr>
             <a:lvl6pPr>
+              <a:buNone/>
               <a:defRPr sz="2325"/>
             </a:lvl6pPr>
             <a:lvl7pPr>
+              <a:buNone/>
               <a:defRPr sz="2325"/>
             </a:lvl7pPr>
             <a:lvl8pPr>
+              <a:buNone/>
               <a:defRPr sz="2325"/>
             </a:lvl8pPr>
             <a:lvl9pPr>
+              <a:buNone/>
               <a:defRPr sz="2325"/>
             </a:lvl9pPr>
           </a:lstStyle>
           <a:p xmlns:a="http://schemas.openxmlformats.org/drawingml/2006/main">
             <a:pPr>
+              <a:buNone/>
               <a:defRPr sz="2325"/>
             </a:pPr>
             <a:r>
@@ -5464,35 +5583,45 @@
               <a:defRPr sz="2475"/>
             </a:defPPr>
             <a:lvl1pPr>
+              <a:buNone/>
               <a:defRPr sz="2475"/>
             </a:lvl1pPr>
             <a:lvl2pPr>
+              <a:buNone/>
               <a:defRPr sz="2475"/>
             </a:lvl2pPr>
             <a:lvl3pPr>
+              <a:buNone/>
               <a:defRPr sz="2475"/>
             </a:lvl3pPr>
             <a:lvl4pPr>
+              <a:buNone/>
               <a:defRPr sz="2475"/>
             </a:lvl4pPr>
             <a:lvl5pPr>
+              <a:buNone/>
               <a:defRPr sz="2475"/>
             </a:lvl5pPr>
             <a:lvl6pPr>
+              <a:buNone/>
               <a:defRPr sz="2475"/>
             </a:lvl6pPr>
             <a:lvl7pPr>
+              <a:buNone/>
               <a:defRPr sz="2475"/>
             </a:lvl7pPr>
             <a:lvl8pPr>
+              <a:buNone/>
               <a:defRPr sz="2475"/>
             </a:lvl8pPr>
             <a:lvl9pPr>
+              <a:buNone/>
               <a:defRPr sz="2475"/>
             </a:lvl9pPr>
           </a:lstStyle>
           <a:p xmlns:a="http://schemas.openxmlformats.org/drawingml/2006/main">
             <a:pPr>
+              <a:buNone/>
               <a:defRPr sz="2475"/>
             </a:pPr>
             <a:r>
@@ -5564,35 +5693,45 @@
               <a:defRPr sz="2175"/>
             </a:defPPr>
             <a:lvl1pPr>
+              <a:buNone/>
               <a:defRPr sz="2175"/>
             </a:lvl1pPr>
             <a:lvl2pPr>
+              <a:buNone/>
               <a:defRPr sz="2175"/>
             </a:lvl2pPr>
             <a:lvl3pPr>
+              <a:buNone/>
               <a:defRPr sz="2175"/>
             </a:lvl3pPr>
             <a:lvl4pPr>
+              <a:buNone/>
               <a:defRPr sz="2175"/>
             </a:lvl4pPr>
             <a:lvl5pPr>
+              <a:buNone/>
               <a:defRPr sz="2175"/>
             </a:lvl5pPr>
             <a:lvl6pPr>
+              <a:buNone/>
               <a:defRPr sz="2175"/>
             </a:lvl6pPr>
             <a:lvl7pPr>
+              <a:buNone/>
               <a:defRPr sz="2175"/>
             </a:lvl7pPr>
             <a:lvl8pPr>
+              <a:buNone/>
               <a:defRPr sz="2175"/>
             </a:lvl8pPr>
             <a:lvl9pPr>
+              <a:buNone/>
               <a:defRPr sz="2175"/>
             </a:lvl9pPr>
           </a:lstStyle>
           <a:p xmlns:a="http://schemas.openxmlformats.org/drawingml/2006/main">
             <a:pPr>
+              <a:buNone/>
               <a:defRPr sz="2175"/>
             </a:pPr>
             <a:r>
@@ -5664,35 +5803,45 @@
               <a:defRPr sz="1725"/>
             </a:defPPr>
             <a:lvl1pPr>
+              <a:buNone/>
               <a:defRPr sz="1725"/>
             </a:lvl1pPr>
             <a:lvl2pPr>
+              <a:buNone/>
               <a:defRPr sz="1725"/>
             </a:lvl2pPr>
             <a:lvl3pPr>
+              <a:buNone/>
               <a:defRPr sz="1725"/>
             </a:lvl3pPr>
             <a:lvl4pPr>
+              <a:buNone/>
               <a:defRPr sz="1725"/>
             </a:lvl4pPr>
             <a:lvl5pPr>
+              <a:buNone/>
               <a:defRPr sz="1725"/>
             </a:lvl5pPr>
             <a:lvl6pPr>
+              <a:buNone/>
               <a:defRPr sz="1725"/>
             </a:lvl6pPr>
             <a:lvl7pPr>
+              <a:buNone/>
               <a:defRPr sz="1725"/>
             </a:lvl7pPr>
             <a:lvl8pPr>
+              <a:buNone/>
               <a:defRPr sz="1725"/>
             </a:lvl8pPr>
             <a:lvl9pPr>
+              <a:buNone/>
               <a:defRPr sz="1725"/>
             </a:lvl9pPr>
           </a:lstStyle>
           <a:p xmlns:a="http://schemas.openxmlformats.org/drawingml/2006/main">
             <a:pPr>
+              <a:buNone/>
               <a:defRPr sz="1725"/>
             </a:pPr>
             <a:r>
@@ -5772,35 +5921,45 @@
               <a:defRPr sz="3300"/>
             </a:defPPr>
             <a:lvl1pPr>
+              <a:buNone/>
               <a:defRPr sz="3300"/>
             </a:lvl1pPr>
             <a:lvl2pPr>
+              <a:buNone/>
               <a:defRPr sz="3300"/>
             </a:lvl2pPr>
             <a:lvl3pPr>
+              <a:buNone/>
               <a:defRPr sz="3300"/>
             </a:lvl3pPr>
             <a:lvl4pPr>
+              <a:buNone/>
               <a:defRPr sz="3300"/>
             </a:lvl4pPr>
             <a:lvl5pPr>
+              <a:buNone/>
               <a:defRPr sz="3300"/>
             </a:lvl5pPr>
             <a:lvl6pPr>
+              <a:buNone/>
               <a:defRPr sz="3300"/>
             </a:lvl6pPr>
             <a:lvl7pPr>
+              <a:buNone/>
               <a:defRPr sz="3300"/>
             </a:lvl7pPr>
             <a:lvl8pPr>
+              <a:buNone/>
               <a:defRPr sz="3300"/>
             </a:lvl8pPr>
             <a:lvl9pPr>
+              <a:buNone/>
               <a:defRPr sz="3300"/>
             </a:lvl9pPr>
           </a:lstStyle>
           <a:p xmlns:a="http://schemas.openxmlformats.org/drawingml/2006/main">
             <a:pPr>
+              <a:buNone/>
               <a:defRPr sz="3300"/>
             </a:pPr>
             <a:r>
@@ -5817,28 +5976,6 @@
           </a:p>
         </p:txBody>
       </p:sp>
-      <p:graphicFrame>
-        <p:nvGraphicFramePr>
-          <p:cNvPr id="2" name="Chart">
-            <a:extLst xmlns:a="http://schemas.openxmlformats.org/drawingml/2006/main">
-              <a:ext uri="{FF2B5EF4-FFF2-40B4-BE49-F238E27FC236}">
-                <a16:creationId xmlns:a16="http://schemas.microsoft.com/office/drawing/2014/main" id="{FC86EA25-B209-4C6F-AF34-AB49A51F85D3}"/>
-              </a:ext>
-            </a:extLst>
-          </p:cNvPr>
-          <p:cNvGraphicFramePr/>
-          <p:nvPr/>
-        </p:nvGraphicFramePr>
-        <p:xfrm>
-          <a:off xmlns:a="http://schemas.openxmlformats.org/drawingml/2006/main" x="571500" y="1666875"/>
-          <a:ext xmlns:a="http://schemas.openxmlformats.org/drawingml/2006/main" cx="6762750" cy="4191000"/>
-        </p:xfrm>
-        <a:graphic xmlns:a="http://schemas.openxmlformats.org/drawingml/2006/main">
-          <a:graphicData uri="http://schemas.openxmlformats.org/drawingml/2006/chart">
-            <c:chart xmlns:r="http://schemas.openxmlformats.org/officeDocument/2006/relationships" xmlns:c="http://schemas.openxmlformats.org/drawingml/2006/chart" r:id="Rd3e64437c672486d"/>
-          </a:graphicData>
-        </a:graphic>
-      </p:graphicFrame>
       <p:sp>
         <p:nvSpPr>
           <p:cNvPr id="3" name="">
@@ -5873,35 +6010,45 @@
               <a:defRPr sz="2475"/>
             </a:defPPr>
             <a:lvl1pPr>
+              <a:buNone/>
               <a:defRPr sz="2475"/>
             </a:lvl1pPr>
             <a:lvl2pPr>
+              <a:buNone/>
               <a:defRPr sz="2475"/>
             </a:lvl2pPr>
             <a:lvl3pPr>
+              <a:buNone/>
               <a:defRPr sz="2475"/>
             </a:lvl3pPr>
             <a:lvl4pPr>
+              <a:buNone/>
               <a:defRPr sz="2475"/>
             </a:lvl4pPr>
             <a:lvl5pPr>
+              <a:buNone/>
               <a:defRPr sz="2475"/>
             </a:lvl5pPr>
             <a:lvl6pPr>
+              <a:buNone/>
               <a:defRPr sz="2475"/>
             </a:lvl6pPr>
             <a:lvl7pPr>
+              <a:buNone/>
               <a:defRPr sz="2475"/>
             </a:lvl7pPr>
             <a:lvl8pPr>
+              <a:buNone/>
               <a:defRPr sz="2475"/>
             </a:lvl8pPr>
             <a:lvl9pPr>
+              <a:buNone/>
               <a:defRPr sz="2475"/>
             </a:lvl9pPr>
           </a:lstStyle>
           <a:p xmlns:a="http://schemas.openxmlformats.org/drawingml/2006/main">
             <a:pPr>
+              <a:buNone/>
               <a:defRPr sz="2475"/>
             </a:pPr>
             <a:r>
@@ -5973,35 +6120,45 @@
               <a:defRPr sz="2100"/>
             </a:defPPr>
             <a:lvl1pPr>
+              <a:buNone/>
               <a:defRPr sz="2100"/>
             </a:lvl1pPr>
             <a:lvl2pPr>
+              <a:buNone/>
               <a:defRPr sz="2100"/>
             </a:lvl2pPr>
             <a:lvl3pPr>
+              <a:buNone/>
               <a:defRPr sz="2100"/>
             </a:lvl3pPr>
             <a:lvl4pPr>
+              <a:buNone/>
               <a:defRPr sz="2100"/>
             </a:lvl4pPr>
             <a:lvl5pPr>
+              <a:buNone/>
               <a:defRPr sz="2100"/>
             </a:lvl5pPr>
             <a:lvl6pPr>
+              <a:buNone/>
               <a:defRPr sz="2100"/>
             </a:lvl6pPr>
             <a:lvl7pPr>
+              <a:buNone/>
               <a:defRPr sz="2100"/>
             </a:lvl7pPr>
             <a:lvl8pPr>
+              <a:buNone/>
               <a:defRPr sz="2100"/>
             </a:lvl8pPr>
             <a:lvl9pPr>
+              <a:buNone/>
               <a:defRPr sz="2100"/>
             </a:lvl9pPr>
           </a:lstStyle>
           <a:p xmlns:a="http://schemas.openxmlformats.org/drawingml/2006/main">
             <a:pPr>
+              <a:buNone/>
               <a:defRPr sz="2100"/>
             </a:pPr>
             <a:r>
@@ -6015,7 +6172,13 @@
               </a:rPr>
               <a:t>Ошибка после подбора</a:t>
             </a:r>
-            <a:br>
+          </a:p>
+          <a:p xmlns:a="http://schemas.openxmlformats.org/drawingml/2006/main">
+            <a:pPr>
+              <a:buNone/>
+              <a:defRPr sz="2100"/>
+            </a:pPr>
+            <a:r>
               <a:rPr sz="2100" b="0">
                 <a:solidFill>
                   <a:srgbClr val="253341"/>
@@ -6024,17 +6187,7 @@
                 <a:ea typeface="Helvetica Neue"/>
                 <a:cs typeface="Helvetica Neue"/>
               </a:rPr>
-            </a:br>
-            <a:r>
-              <a:rPr sz="2100" b="0">
-                <a:solidFill>
-                  <a:srgbClr val="253341"/>
-                </a:solidFill>
-                <a:latin typeface="Helvetica Neue"/>
-                <a:ea typeface="Helvetica Neue"/>
-                <a:cs typeface="Helvetica Neue"/>
-              </a:rPr>
-              <a:t>≈ 1.14% при всех α</a:t>
+              <a:t>≈ 1,14% при всех α</a:t>
             </a:r>
           </a:p>
         </p:txBody>
@@ -6073,35 +6226,45 @@
               <a:defRPr sz="2100"/>
             </a:defPPr>
             <a:lvl1pPr>
+              <a:buNone/>
               <a:defRPr sz="2100"/>
             </a:lvl1pPr>
             <a:lvl2pPr>
+              <a:buNone/>
               <a:defRPr sz="2100"/>
             </a:lvl2pPr>
             <a:lvl3pPr>
+              <a:buNone/>
               <a:defRPr sz="2100"/>
             </a:lvl3pPr>
             <a:lvl4pPr>
+              <a:buNone/>
               <a:defRPr sz="2100"/>
             </a:lvl4pPr>
             <a:lvl5pPr>
+              <a:buNone/>
               <a:defRPr sz="2100"/>
             </a:lvl5pPr>
             <a:lvl6pPr>
+              <a:buNone/>
               <a:defRPr sz="2100"/>
             </a:lvl6pPr>
             <a:lvl7pPr>
+              <a:buNone/>
               <a:defRPr sz="2100"/>
             </a:lvl7pPr>
             <a:lvl8pPr>
+              <a:buNone/>
               <a:defRPr sz="2100"/>
             </a:lvl8pPr>
             <a:lvl9pPr>
+              <a:buNone/>
               <a:defRPr sz="2100"/>
             </a:lvl9pPr>
           </a:lstStyle>
           <a:p xmlns:a="http://schemas.openxmlformats.org/drawingml/2006/main">
             <a:pPr>
+              <a:buNone/>
               <a:defRPr sz="2100"/>
             </a:pPr>
             <a:r>
@@ -6139,6 +6302,28 @@
           </a:p>
         </p:txBody>
       </p:sp>
+      <p:graphicFrame>
+        <p:nvGraphicFramePr>
+          <p:cNvPr id="7" name="Chart">
+            <a:extLst xmlns:a="http://schemas.openxmlformats.org/drawingml/2006/main">
+              <a:ext uri="{FF2B5EF4-FFF2-40B4-BE49-F238E27FC236}">
+                <a16:creationId xmlns:a16="http://schemas.microsoft.com/office/drawing/2014/main" id="{FB4BB8F9-A2B8-478F-A11D-FDD4B79A3438}"/>
+              </a:ext>
+            </a:extLst>
+          </p:cNvPr>
+          <p:cNvGraphicFramePr/>
+          <p:nvPr/>
+        </p:nvGraphicFramePr>
+        <p:xfrm>
+          <a:off xmlns:a="http://schemas.openxmlformats.org/drawingml/2006/main" x="571500" y="1666875"/>
+          <a:ext xmlns:a="http://schemas.openxmlformats.org/drawingml/2006/main" cx="6762750" cy="4191000"/>
+        </p:xfrm>
+        <a:graphic xmlns:a="http://schemas.openxmlformats.org/drawingml/2006/main">
+          <a:graphicData uri="http://schemas.openxmlformats.org/drawingml/2006/chart">
+            <c:chart xmlns:r="http://schemas.openxmlformats.org/officeDocument/2006/relationships" xmlns:c="http://schemas.openxmlformats.org/drawingml/2006/chart" r:id="R80fadc9c4d2b4e62"/>
+          </a:graphicData>
+        </a:graphic>
+      </p:graphicFrame>
     </p:spTree>
     <p:extLst>
       <p:ext uri="{BB962C8B-B14F-4D97-AF65-F5344CB8AC3E}">
@@ -6202,35 +6387,45 @@
               <a:defRPr sz="3300"/>
             </a:defPPr>
             <a:lvl1pPr>
+              <a:buNone/>
               <a:defRPr sz="3300"/>
             </a:lvl1pPr>
             <a:lvl2pPr>
+              <a:buNone/>
               <a:defRPr sz="3300"/>
             </a:lvl2pPr>
             <a:lvl3pPr>
+              <a:buNone/>
               <a:defRPr sz="3300"/>
             </a:lvl3pPr>
             <a:lvl4pPr>
+              <a:buNone/>
               <a:defRPr sz="3300"/>
             </a:lvl4pPr>
             <a:lvl5pPr>
+              <a:buNone/>
               <a:defRPr sz="3300"/>
             </a:lvl5pPr>
             <a:lvl6pPr>
+              <a:buNone/>
               <a:defRPr sz="3300"/>
             </a:lvl6pPr>
             <a:lvl7pPr>
+              <a:buNone/>
               <a:defRPr sz="3300"/>
             </a:lvl7pPr>
             <a:lvl8pPr>
+              <a:buNone/>
               <a:defRPr sz="3300"/>
             </a:lvl8pPr>
             <a:lvl9pPr>
+              <a:buNone/>
               <a:defRPr sz="3300"/>
             </a:lvl9pPr>
           </a:lstStyle>
           <a:p xmlns:a="http://schemas.openxmlformats.org/drawingml/2006/main">
             <a:pPr>
+              <a:buNone/>
               <a:defRPr sz="3300"/>
             </a:pPr>
             <a:r>
@@ -6247,28 +6442,6 @@
           </a:p>
         </p:txBody>
       </p:sp>
-      <p:graphicFrame>
-        <p:nvGraphicFramePr>
-          <p:cNvPr id="2" name="Chart">
-            <a:extLst xmlns:a="http://schemas.openxmlformats.org/drawingml/2006/main">
-              <a:ext uri="{FF2B5EF4-FFF2-40B4-BE49-F238E27FC236}">
-                <a16:creationId xmlns:a16="http://schemas.microsoft.com/office/drawing/2014/main" id="{CFCFA290-F571-4557-8246-AB9D5418A995}"/>
-              </a:ext>
-            </a:extLst>
-          </p:cNvPr>
-          <p:cNvGraphicFramePr/>
-          <p:nvPr/>
-        </p:nvGraphicFramePr>
-        <p:xfrm>
-          <a:off xmlns:a="http://schemas.openxmlformats.org/drawingml/2006/main" x="571500" y="1666875"/>
-          <a:ext xmlns:a="http://schemas.openxmlformats.org/drawingml/2006/main" cx="6762750" cy="4191000"/>
-        </p:xfrm>
-        <a:graphic xmlns:a="http://schemas.openxmlformats.org/drawingml/2006/main">
-          <a:graphicData uri="http://schemas.openxmlformats.org/drawingml/2006/chart">
-            <c:chart xmlns:r="http://schemas.openxmlformats.org/officeDocument/2006/relationships" xmlns:c="http://schemas.openxmlformats.org/drawingml/2006/chart" r:id="Rdf217d979b644de7"/>
-          </a:graphicData>
-        </a:graphic>
-      </p:graphicFrame>
       <p:sp>
         <p:nvSpPr>
           <p:cNvPr id="3" name="">
@@ -6303,35 +6476,45 @@
               <a:defRPr sz="2775"/>
             </a:defPPr>
             <a:lvl1pPr>
+              <a:buNone/>
               <a:defRPr sz="2775"/>
             </a:lvl1pPr>
             <a:lvl2pPr>
+              <a:buNone/>
               <a:defRPr sz="2775"/>
             </a:lvl2pPr>
             <a:lvl3pPr>
+              <a:buNone/>
               <a:defRPr sz="2775"/>
             </a:lvl3pPr>
             <a:lvl4pPr>
+              <a:buNone/>
               <a:defRPr sz="2775"/>
             </a:lvl4pPr>
             <a:lvl5pPr>
+              <a:buNone/>
               <a:defRPr sz="2775"/>
             </a:lvl5pPr>
             <a:lvl6pPr>
+              <a:buNone/>
               <a:defRPr sz="2775"/>
             </a:lvl6pPr>
             <a:lvl7pPr>
+              <a:buNone/>
               <a:defRPr sz="2775"/>
             </a:lvl7pPr>
             <a:lvl8pPr>
+              <a:buNone/>
               <a:defRPr sz="2775"/>
             </a:lvl8pPr>
             <a:lvl9pPr>
+              <a:buNone/>
               <a:defRPr sz="2775"/>
             </a:lvl9pPr>
           </a:lstStyle>
           <a:p xmlns:a="http://schemas.openxmlformats.org/drawingml/2006/main">
             <a:pPr>
+              <a:buNone/>
               <a:defRPr sz="2775"/>
             </a:pPr>
             <a:r>
@@ -6343,7 +6526,7 @@
                 <a:ea typeface="Helvetica Neue"/>
                 <a:cs typeface="Helvetica Neue"/>
               </a:rPr>
-              <a:t>0.27% → 45.25%</a:t>
+              <a:t>0,26% → 45,27%</a:t>
             </a:r>
           </a:p>
         </p:txBody>
@@ -6382,35 +6565,45 @@
               <a:defRPr sz="2100"/>
             </a:defPPr>
             <a:lvl1pPr>
+              <a:buNone/>
               <a:defRPr sz="2100"/>
             </a:lvl1pPr>
             <a:lvl2pPr>
+              <a:buNone/>
               <a:defRPr sz="2100"/>
             </a:lvl2pPr>
             <a:lvl3pPr>
+              <a:buNone/>
               <a:defRPr sz="2100"/>
             </a:lvl3pPr>
             <a:lvl4pPr>
+              <a:buNone/>
               <a:defRPr sz="2100"/>
             </a:lvl4pPr>
             <a:lvl5pPr>
+              <a:buNone/>
               <a:defRPr sz="2100"/>
             </a:lvl5pPr>
             <a:lvl6pPr>
+              <a:buNone/>
               <a:defRPr sz="2100"/>
             </a:lvl6pPr>
             <a:lvl7pPr>
+              <a:buNone/>
               <a:defRPr sz="2100"/>
             </a:lvl7pPr>
             <a:lvl8pPr>
+              <a:buNone/>
               <a:defRPr sz="2100"/>
             </a:lvl8pPr>
             <a:lvl9pPr>
+              <a:buNone/>
               <a:defRPr sz="2100"/>
             </a:lvl9pPr>
           </a:lstStyle>
           <a:p xmlns:a="http://schemas.openxmlformats.org/drawingml/2006/main">
             <a:pPr>
+              <a:buNone/>
               <a:defRPr sz="2100"/>
             </a:pPr>
             <a:r>
@@ -6482,35 +6675,45 @@
               <a:defRPr sz="2250"/>
             </a:defPPr>
             <a:lvl1pPr>
+              <a:buNone/>
               <a:defRPr sz="2250"/>
             </a:lvl1pPr>
             <a:lvl2pPr>
+              <a:buNone/>
               <a:defRPr sz="2250"/>
             </a:lvl2pPr>
             <a:lvl3pPr>
+              <a:buNone/>
               <a:defRPr sz="2250"/>
             </a:lvl3pPr>
             <a:lvl4pPr>
+              <a:buNone/>
               <a:defRPr sz="2250"/>
             </a:lvl4pPr>
             <a:lvl5pPr>
+              <a:buNone/>
               <a:defRPr sz="2250"/>
             </a:lvl5pPr>
             <a:lvl6pPr>
+              <a:buNone/>
               <a:defRPr sz="2250"/>
             </a:lvl6pPr>
             <a:lvl7pPr>
+              <a:buNone/>
               <a:defRPr sz="2250"/>
             </a:lvl7pPr>
             <a:lvl8pPr>
+              <a:buNone/>
               <a:defRPr sz="2250"/>
             </a:lvl8pPr>
             <a:lvl9pPr>
+              <a:buNone/>
               <a:defRPr sz="2250"/>
             </a:lvl9pPr>
           </a:lstStyle>
           <a:p xmlns:a="http://schemas.openxmlformats.org/drawingml/2006/main">
             <a:pPr>
+              <a:buNone/>
               <a:defRPr sz="2250"/>
             </a:pPr>
             <a:r>
@@ -6522,7 +6725,7 @@
                 <a:ea typeface="Helvetica Neue"/>
                 <a:cs typeface="Helvetica Neue"/>
               </a:rPr>
-              <a:t>KL(P₀ ∥ P₁) ≈ 250 нат</a:t>
+              <a:t>KL(P₀ ∥ P₁) ≈ 253 нат</a:t>
             </a:r>
           </a:p>
         </p:txBody>
@@ -6561,35 +6764,45 @@
               <a:defRPr sz="1650"/>
             </a:defPPr>
             <a:lvl1pPr>
+              <a:buNone/>
               <a:defRPr sz="1650"/>
             </a:lvl1pPr>
             <a:lvl2pPr>
+              <a:buNone/>
               <a:defRPr sz="1650"/>
             </a:lvl2pPr>
             <a:lvl3pPr>
+              <a:buNone/>
               <a:defRPr sz="1650"/>
             </a:lvl3pPr>
             <a:lvl4pPr>
+              <a:buNone/>
               <a:defRPr sz="1650"/>
             </a:lvl4pPr>
             <a:lvl5pPr>
+              <a:buNone/>
               <a:defRPr sz="1650"/>
             </a:lvl5pPr>
             <a:lvl6pPr>
+              <a:buNone/>
               <a:defRPr sz="1650"/>
             </a:lvl6pPr>
             <a:lvl7pPr>
+              <a:buNone/>
               <a:defRPr sz="1650"/>
             </a:lvl7pPr>
             <a:lvl8pPr>
+              <a:buNone/>
               <a:defRPr sz="1650"/>
             </a:lvl8pPr>
             <a:lvl9pPr>
+              <a:buNone/>
               <a:defRPr sz="1650"/>
             </a:lvl9pPr>
           </a:lstStyle>
           <a:p xmlns:a="http://schemas.openxmlformats.org/drawingml/2006/main">
             <a:pPr>
+              <a:buNone/>
               <a:defRPr sz="1650"/>
             </a:pPr>
             <a:r>
@@ -6606,6 +6819,28 @@
           </a:p>
         </p:txBody>
       </p:sp>
+      <p:graphicFrame>
+        <p:nvGraphicFramePr>
+          <p:cNvPr id="8" name="Chart">
+            <a:extLst xmlns:a="http://schemas.openxmlformats.org/drawingml/2006/main">
+              <a:ext uri="{FF2B5EF4-FFF2-40B4-BE49-F238E27FC236}">
+                <a16:creationId xmlns:a16="http://schemas.microsoft.com/office/drawing/2014/main" id="{4B197D99-16D4-4122-8FD0-596B54997DE5}"/>
+              </a:ext>
+            </a:extLst>
+          </p:cNvPr>
+          <p:cNvGraphicFramePr/>
+          <p:nvPr/>
+        </p:nvGraphicFramePr>
+        <p:xfrm>
+          <a:off xmlns:a="http://schemas.openxmlformats.org/drawingml/2006/main" x="571500" y="1666875"/>
+          <a:ext xmlns:a="http://schemas.openxmlformats.org/drawingml/2006/main" cx="6762750" cy="4191000"/>
+        </p:xfrm>
+        <a:graphic xmlns:a="http://schemas.openxmlformats.org/drawingml/2006/main">
+          <a:graphicData uri="http://schemas.openxmlformats.org/drawingml/2006/chart">
+            <c:chart xmlns:r="http://schemas.openxmlformats.org/officeDocument/2006/relationships" xmlns:c="http://schemas.openxmlformats.org/drawingml/2006/chart" r:id="R32226ee3938f4a83"/>
+          </a:graphicData>
+        </a:graphic>
+      </p:graphicFrame>
     </p:spTree>
     <p:extLst>
       <p:ext uri="{BB962C8B-B14F-4D97-AF65-F5344CB8AC3E}">
@@ -6669,35 +6904,45 @@
               <a:defRPr sz="3300"/>
             </a:defPPr>
             <a:lvl1pPr>
+              <a:buNone/>
               <a:defRPr sz="3300"/>
             </a:lvl1pPr>
             <a:lvl2pPr>
+              <a:buNone/>
               <a:defRPr sz="3300"/>
             </a:lvl2pPr>
             <a:lvl3pPr>
+              <a:buNone/>
               <a:defRPr sz="3300"/>
             </a:lvl3pPr>
             <a:lvl4pPr>
+              <a:buNone/>
               <a:defRPr sz="3300"/>
             </a:lvl4pPr>
             <a:lvl5pPr>
+              <a:buNone/>
               <a:defRPr sz="3300"/>
             </a:lvl5pPr>
             <a:lvl6pPr>
+              <a:buNone/>
               <a:defRPr sz="3300"/>
             </a:lvl6pPr>
             <a:lvl7pPr>
+              <a:buNone/>
               <a:defRPr sz="3300"/>
             </a:lvl7pPr>
             <a:lvl8pPr>
+              <a:buNone/>
               <a:defRPr sz="3300"/>
             </a:lvl8pPr>
             <a:lvl9pPr>
+              <a:buNone/>
               <a:defRPr sz="3300"/>
             </a:lvl9pPr>
           </a:lstStyle>
           <a:p xmlns:a="http://schemas.openxmlformats.org/drawingml/2006/main">
             <a:pPr>
+              <a:buNone/>
               <a:defRPr sz="3300"/>
             </a:pPr>
             <a:r>
@@ -6748,35 +6993,45 @@
               <a:defRPr sz="2775"/>
             </a:defPPr>
             <a:lvl1pPr>
+              <a:buNone/>
               <a:defRPr sz="2775"/>
             </a:lvl1pPr>
             <a:lvl2pPr>
+              <a:buNone/>
               <a:defRPr sz="2775"/>
             </a:lvl2pPr>
             <a:lvl3pPr>
+              <a:buNone/>
               <a:defRPr sz="2775"/>
             </a:lvl3pPr>
             <a:lvl4pPr>
+              <a:buNone/>
               <a:defRPr sz="2775"/>
             </a:lvl4pPr>
             <a:lvl5pPr>
+              <a:buNone/>
               <a:defRPr sz="2775"/>
             </a:lvl5pPr>
             <a:lvl6pPr>
+              <a:buNone/>
               <a:defRPr sz="2775"/>
             </a:lvl6pPr>
             <a:lvl7pPr>
+              <a:buNone/>
               <a:defRPr sz="2775"/>
             </a:lvl7pPr>
             <a:lvl8pPr>
+              <a:buNone/>
               <a:defRPr sz="2775"/>
             </a:lvl8pPr>
             <a:lvl9pPr>
+              <a:buNone/>
               <a:defRPr sz="2775"/>
             </a:lvl9pPr>
           </a:lstStyle>
           <a:p xmlns:a="http://schemas.openxmlformats.org/drawingml/2006/main">
             <a:pPr>
+              <a:buNone/>
               <a:defRPr sz="2775"/>
             </a:pPr>
             <a:r>
@@ -6827,35 +7082,45 @@
               <a:defRPr sz="2100"/>
             </a:defPPr>
             <a:lvl1pPr>
+              <a:buNone/>
               <a:defRPr sz="2100"/>
             </a:lvl1pPr>
             <a:lvl2pPr>
+              <a:buNone/>
               <a:defRPr sz="2100"/>
             </a:lvl2pPr>
             <a:lvl3pPr>
+              <a:buNone/>
               <a:defRPr sz="2100"/>
             </a:lvl3pPr>
             <a:lvl4pPr>
+              <a:buNone/>
               <a:defRPr sz="2100"/>
             </a:lvl4pPr>
             <a:lvl5pPr>
+              <a:buNone/>
               <a:defRPr sz="2100"/>
             </a:lvl5pPr>
             <a:lvl6pPr>
+              <a:buNone/>
               <a:defRPr sz="2100"/>
             </a:lvl6pPr>
             <a:lvl7pPr>
+              <a:buNone/>
               <a:defRPr sz="2100"/>
             </a:lvl7pPr>
             <a:lvl8pPr>
+              <a:buNone/>
               <a:defRPr sz="2100"/>
             </a:lvl8pPr>
             <a:lvl9pPr>
+              <a:buNone/>
               <a:defRPr sz="2100"/>
             </a:lvl9pPr>
           </a:lstStyle>
           <a:p xmlns:a="http://schemas.openxmlformats.org/drawingml/2006/main">
             <a:pPr>
+              <a:buNone/>
               <a:defRPr sz="2100"/>
             </a:pPr>
             <a:r>
@@ -6906,35 +7171,45 @@
               <a:defRPr sz="2250"/>
             </a:defPPr>
             <a:lvl1pPr>
+              <a:buNone/>
               <a:defRPr sz="2250"/>
             </a:lvl1pPr>
             <a:lvl2pPr>
+              <a:buNone/>
               <a:defRPr sz="2250"/>
             </a:lvl2pPr>
             <a:lvl3pPr>
+              <a:buNone/>
               <a:defRPr sz="2250"/>
             </a:lvl3pPr>
             <a:lvl4pPr>
+              <a:buNone/>
               <a:defRPr sz="2250"/>
             </a:lvl4pPr>
             <a:lvl5pPr>
+              <a:buNone/>
               <a:defRPr sz="2250"/>
             </a:lvl5pPr>
             <a:lvl6pPr>
+              <a:buNone/>
               <a:defRPr sz="2250"/>
             </a:lvl6pPr>
             <a:lvl7pPr>
+              <a:buNone/>
               <a:defRPr sz="2250"/>
             </a:lvl7pPr>
             <a:lvl8pPr>
+              <a:buNone/>
               <a:defRPr sz="2250"/>
             </a:lvl8pPr>
             <a:lvl9pPr>
+              <a:buNone/>
               <a:defRPr sz="2250"/>
             </a:lvl9pPr>
           </a:lstStyle>
           <a:p xmlns:a="http://schemas.openxmlformats.org/drawingml/2006/main">
             <a:pPr>
+              <a:buNone/>
               <a:defRPr sz="2250"/>
             </a:pPr>
             <a:r>
@@ -6985,35 +7260,45 @@
               <a:defRPr sz="2025"/>
             </a:defPPr>
             <a:lvl1pPr>
+              <a:buNone/>
               <a:defRPr sz="2025"/>
             </a:lvl1pPr>
             <a:lvl2pPr>
+              <a:buNone/>
               <a:defRPr sz="2025"/>
             </a:lvl2pPr>
             <a:lvl3pPr>
+              <a:buNone/>
               <a:defRPr sz="2025"/>
             </a:lvl3pPr>
             <a:lvl4pPr>
+              <a:buNone/>
               <a:defRPr sz="2025"/>
             </a:lvl4pPr>
             <a:lvl5pPr>
+              <a:buNone/>
               <a:defRPr sz="2025"/>
             </a:lvl5pPr>
             <a:lvl6pPr>
+              <a:buNone/>
               <a:defRPr sz="2025"/>
             </a:lvl6pPr>
             <a:lvl7pPr>
+              <a:buNone/>
               <a:defRPr sz="2025"/>
             </a:lvl7pPr>
             <a:lvl8pPr>
+              <a:buNone/>
               <a:defRPr sz="2025"/>
             </a:lvl8pPr>
             <a:lvl9pPr>
+              <a:buNone/>
               <a:defRPr sz="2025"/>
             </a:lvl9pPr>
           </a:lstStyle>
           <a:p xmlns:a="http://schemas.openxmlformats.org/drawingml/2006/main">
             <a:pPr>
+              <a:buNone/>
               <a:defRPr sz="2025"/>
             </a:pPr>
             <a:r>

</xml_diff>